<commit_message>
sd-07-002: scope one address to one network; keep rail-dependent timing in the quiz answer
The lesson, figure and deck said a blockchain wallet is one address on
one shared ledger. Each network is its own ledger, so assets on Bitcoin
and Ethereum need separate addresses; the claim is now scoped to one
network. The quiz answer still stated end-of-day settlement as the rule;
it now keeps the source's simplified model and says the timing depends
on the transfer system. Deck slides 1, 5, 7 and 9 edited, PPTX re-exported.

Co-Authored-By: Claude Opus 5.5 <noreply@anthropic.com>
Claude-Session: https://claude.ai/code/session_01TDEQZkTojRsEuCWxmNaEbL
</commit_message>
<xml_diff>
--- a/system-design-101/vi/lessons/sd-07-002/slides/sd-07-002.pptx
+++ b/system-design-101/vi/lessons/sd-07-002/slides/sd-07-002.pptx
@@ -1869,7 +1869,40 @@
                 <a:ea typeface="Be Vietnam Pro" pitchFamily="34" charset="-122"/>
                 <a:cs typeface="Be Vietnam Pro" pitchFamily="34" charset="-120"/>
               </a:rPr>
-              <a:t> sao sổ</a:t>
+              <a:t> sao</a:t>
+            </a:r>
+            <a:r>
+              <a:rPr lang="en-US" sz="3000" dirty="0" spc="4" kern="0">
+                <a:solidFill>
+                  <a:srgbClr val="E4E1D8"/>
+                </a:solidFill>
+                <a:latin typeface="Be Vietnam Pro" pitchFamily="34" charset="0"/>
+                <a:ea typeface="Be Vietnam Pro" pitchFamily="34" charset="-122"/>
+                <a:cs typeface="Be Vietnam Pro" pitchFamily="34" charset="-120"/>
+              </a:rPr>
+              <a:t> có</a:t>
+            </a:r>
+            <a:r>
+              <a:rPr lang="en-US" sz="3000" dirty="0" spc="1" kern="0">
+                <a:solidFill>
+                  <a:srgbClr val="E4E1D8"/>
+                </a:solidFill>
+                <a:latin typeface="Be Vietnam Pro" pitchFamily="34" charset="0"/>
+                <a:ea typeface="Be Vietnam Pro" pitchFamily="34" charset="-122"/>
+                <a:cs typeface="Be Vietnam Pro" pitchFamily="34" charset="-120"/>
+              </a:rPr>
+              <a:t> lúc</a:t>
+            </a:r>
+            <a:r>
+              <a:rPr lang="en-US" sz="3000" dirty="0" spc="-7" kern="0">
+                <a:solidFill>
+                  <a:srgbClr val="E4E1D8"/>
+                </a:solidFill>
+                <a:latin typeface="Be Vietnam Pro" pitchFamily="34" charset="0"/>
+                <a:ea typeface="Be Vietnam Pro" pitchFamily="34" charset="-122"/>
+                <a:cs typeface="Be Vietnam Pro" pitchFamily="34" charset="-120"/>
+              </a:rPr>
+              <a:t> sổ</a:t>
             </a:r>
             <a:r>
               <a:rPr lang="en-US" sz="3000" dirty="0" spc="19" kern="0">
@@ -1927,7 +1960,7 @@
               <a:t> thật</a:t>
             </a:r>
             <a:r>
-              <a:rPr lang="en-US" sz="3000" dirty="0" spc="11" kern="0">
+              <a:rPr lang="en-US" sz="3000" dirty="0" spc="10" kern="0">
                 <a:solidFill>
                   <a:srgbClr val="E4E1D8"/>
                 </a:solidFill>
@@ -2079,7 +2112,40 @@
                 <a:ea typeface="Be Vietnam Pro" pitchFamily="34" charset="-122"/>
                 <a:cs typeface="Be Vietnam Pro" pitchFamily="34" charset="-120"/>
               </a:rPr>
-              <a:t> hay</a:t>
+              <a:t> hay sổ</a:t>
+            </a:r>
+            <a:r>
+              <a:rPr lang="en-US" sz="2100" dirty="0" spc="-1" kern="0">
+                <a:solidFill>
+                  <a:srgbClr val="9AA0B5"/>
+                </a:solidFill>
+                <a:latin typeface="Be Vietnam Pro" pitchFamily="34" charset="0"/>
+                <a:ea typeface="Be Vietnam Pro" pitchFamily="34" charset="-122"/>
+                <a:cs typeface="Be Vietnam Pro" pitchFamily="34" charset="-120"/>
+              </a:rPr>
+              <a:t> cái</a:t>
+            </a:r>
+            <a:r>
+              <a:rPr lang="en-US" sz="2100" dirty="0" spc="0" kern="0">
+                <a:solidFill>
+                  <a:srgbClr val="9AA0B5"/>
+                </a:solidFill>
+                <a:latin typeface="Be Vietnam Pro" pitchFamily="34" charset="0"/>
+                <a:ea typeface="Be Vietnam Pro" pitchFamily="34" charset="-122"/>
+                <a:cs typeface="Be Vietnam Pro" pitchFamily="34" charset="-120"/>
+              </a:rPr>
+              <a:t> chung</a:t>
+            </a:r>
+            <a:r>
+              <a:rPr lang="en-US" sz="2100" dirty="0" spc="-1" kern="0">
+                <a:solidFill>
+                  <a:srgbClr val="9AA0B5"/>
+                </a:solidFill>
+                <a:latin typeface="Be Vietnam Pro" pitchFamily="34" charset="0"/>
+                <a:ea typeface="Be Vietnam Pro" pitchFamily="34" charset="-122"/>
+                <a:cs typeface="Be Vietnam Pro" pitchFamily="34" charset="-120"/>
+              </a:rPr>
+              <a:t> của</a:t>
             </a:r>
             <a:r>
               <a:rPr lang="en-US" sz="2100" dirty="0" spc="-8" kern="0">
@@ -2093,7 +2159,7 @@
               <a:t> một</a:t>
             </a:r>
             <a:r>
-              <a:rPr lang="en-US" sz="2100" dirty="0" spc="-10" kern="0">
+              <a:rPr lang="en-US" sz="2100" dirty="0" spc="-1" kern="0">
                 <a:solidFill>
                   <a:srgbClr val="9AA0B5"/>
                 </a:solidFill>
@@ -2101,29 +2167,7 @@
                 <a:ea typeface="Be Vietnam Pro" pitchFamily="34" charset="-122"/>
                 <a:cs typeface="Be Vietnam Pro" pitchFamily="34" charset="-120"/>
               </a:rPr>
-              <a:t> sổ</a:t>
-            </a:r>
-            <a:r>
-              <a:rPr lang="en-US" sz="2100" dirty="0" spc="-1" kern="0">
-                <a:solidFill>
-                  <a:srgbClr val="9AA0B5"/>
-                </a:solidFill>
-                <a:latin typeface="Be Vietnam Pro" pitchFamily="34" charset="0"/>
-                <a:ea typeface="Be Vietnam Pro" pitchFamily="34" charset="-122"/>
-                <a:cs typeface="Be Vietnam Pro" pitchFamily="34" charset="-120"/>
-              </a:rPr>
-              <a:t> cái</a:t>
-            </a:r>
-            <a:r>
-              <a:rPr lang="en-US" sz="2100" dirty="0" spc="0" kern="0">
-                <a:solidFill>
-                  <a:srgbClr val="9AA0B5"/>
-                </a:solidFill>
-                <a:latin typeface="Be Vietnam Pro" pitchFamily="34" charset="0"/>
-                <a:ea typeface="Be Vietnam Pro" pitchFamily="34" charset="-122"/>
-                <a:cs typeface="Be Vietnam Pro" pitchFamily="34" charset="-120"/>
-              </a:rPr>
-              <a:t> chung</a:t>
+              <a:t> mạng</a:t>
             </a:r>
             <a:endParaRPr lang="en-US" sz="2100" dirty="0"/>
           </a:p>
@@ -7184,7 +7228,7 @@
               <a:buNone/>
             </a:pPr>
             <a:r>
-              <a:rPr lang="en-US" sz="2550" b="1" dirty="0" spc="-11" kern="0">
+              <a:rPr lang="en-US" sz="2550" b="1" dirty="0" spc="1" kern="0">
                 <a:solidFill>
                   <a:srgbClr val="14161C"/>
                 </a:solidFill>
@@ -7192,10 +7236,10 @@
                 <a:ea typeface="Be Vietnam Pro" pitchFamily="34" charset="-122"/>
                 <a:cs typeface="Be Vietnam Pro" pitchFamily="34" charset="-120"/>
               </a:rPr>
-              <a:t>Một</a:t>
-            </a:r>
-            <a:r>
-              <a:rPr lang="en-US" sz="2550" b="1" dirty="0" spc="-4" kern="0">
+              <a:t>Sổ cái</a:t>
+            </a:r>
+            <a:r>
+              <a:rPr lang="en-US" sz="2550" b="1" dirty="0" spc="-1" kern="0">
                 <a:solidFill>
                   <a:srgbClr val="14161C"/>
                 </a:solidFill>
@@ -7203,10 +7247,10 @@
                 <a:ea typeface="Be Vietnam Pro" pitchFamily="34" charset="-122"/>
                 <a:cs typeface="Be Vietnam Pro" pitchFamily="34" charset="-120"/>
               </a:rPr>
-              <a:t> sổ</a:t>
-            </a:r>
-            <a:r>
-              <a:rPr lang="en-US" sz="2550" b="1" dirty="0" spc="1" kern="0">
+              <a:t> chung</a:t>
+            </a:r>
+            <a:r>
+              <a:rPr lang="en-US" sz="2550" b="1" dirty="0" spc="0" kern="0">
                 <a:solidFill>
                   <a:srgbClr val="14161C"/>
                 </a:solidFill>
@@ -7214,10 +7258,10 @@
                 <a:ea typeface="Be Vietnam Pro" pitchFamily="34" charset="-122"/>
                 <a:cs typeface="Be Vietnam Pro" pitchFamily="34" charset="-120"/>
               </a:rPr>
-              <a:t> cái</a:t>
-            </a:r>
-            <a:r>
-              <a:rPr lang="en-US" sz="2550" b="1" dirty="0" spc="-1" kern="0">
+              <a:t> của</a:t>
+            </a:r>
+            <a:r>
+              <a:rPr lang="en-US" sz="2550" b="1" dirty="0" spc="-10" kern="0">
                 <a:solidFill>
                   <a:srgbClr val="14161C"/>
                 </a:solidFill>
@@ -7225,7 +7269,18 @@
                 <a:ea typeface="Be Vietnam Pro" pitchFamily="34" charset="-122"/>
                 <a:cs typeface="Be Vietnam Pro" pitchFamily="34" charset="-120"/>
               </a:rPr>
-              <a:t> chung</a:t>
+              <a:t> một</a:t>
+            </a:r>
+            <a:r>
+              <a:rPr lang="en-US" sz="2550" b="1" dirty="0" spc="-3" kern="0">
+                <a:solidFill>
+                  <a:srgbClr val="14161C"/>
+                </a:solidFill>
+                <a:latin typeface="Be Vietnam Pro" pitchFamily="34" charset="0"/>
+                <a:ea typeface="Be Vietnam Pro" pitchFamily="34" charset="-122"/>
+                <a:cs typeface="Be Vietnam Pro" pitchFamily="34" charset="-120"/>
+              </a:rPr>
+              <a:t> mạng</a:t>
             </a:r>
             <a:endParaRPr lang="en-US" sz="2550" dirty="0"/>
           </a:p>
@@ -7438,7 +7493,7 @@
               <a:t> chỉ</a:t>
             </a:r>
             <a:r>
-              <a:rPr lang="en-US" sz="2550" b="1" dirty="0" spc="-1" kern="0">
+              <a:rPr lang="en-US" sz="2550" b="1" dirty="0" spc="-15" kern="0">
                 <a:solidFill>
                   <a:srgbClr val="14161C"/>
                 </a:solidFill>
@@ -7446,10 +7501,10 @@
                 <a:ea typeface="Be Vietnam Pro" pitchFamily="34" charset="-122"/>
                 <a:cs typeface="Be Vietnam Pro" pitchFamily="34" charset="-120"/>
               </a:rPr>
-              <a:t> duy</a:t>
-            </a:r>
-            <a:r>
-              <a:rPr lang="en-US" sz="2550" b="1" dirty="0" spc="-5" kern="0">
+              <a:t> trên</a:t>
+            </a:r>
+            <a:r>
+              <a:rPr lang="en-US" sz="2550" b="1" dirty="0" spc="-9" kern="0">
                 <a:solidFill>
                   <a:srgbClr val="14161C"/>
                 </a:solidFill>
@@ -7457,7 +7512,18 @@
                 <a:ea typeface="Be Vietnam Pro" pitchFamily="34" charset="-122"/>
                 <a:cs typeface="Be Vietnam Pro" pitchFamily="34" charset="-120"/>
               </a:rPr>
-              <a:t> nhất</a:t>
+              <a:t> một</a:t>
+            </a:r>
+            <a:r>
+              <a:rPr lang="en-US" sz="2550" b="1" dirty="0" spc="-4" kern="0">
+                <a:solidFill>
+                  <a:srgbClr val="14161C"/>
+                </a:solidFill>
+                <a:latin typeface="Be Vietnam Pro" pitchFamily="34" charset="0"/>
+                <a:ea typeface="Be Vietnam Pro" pitchFamily="34" charset="-122"/>
+                <a:cs typeface="Be Vietnam Pro" pitchFamily="34" charset="-120"/>
+              </a:rPr>
+              <a:t> mạng</a:t>
             </a:r>
             <a:endParaRPr lang="en-US" sz="2550" dirty="0"/>
           </a:p>
@@ -7712,7 +7778,40 @@
                 <a:ea typeface="Be Vietnam Pro" pitchFamily="34" charset="-122"/>
                 <a:cs typeface="Be Vietnam Pro" pitchFamily="34" charset="-120"/>
               </a:rPr>
-              <a:t>Gộp</a:t>
+              <a:t>Khác</a:t>
+            </a:r>
+            <a:r>
+              <a:rPr lang="en-US" sz="1950" dirty="0" spc="2" kern="0">
+                <a:solidFill>
+                  <a:srgbClr val="6B6A66"/>
+                </a:solidFill>
+                <a:latin typeface="Be Vietnam Pro" pitchFamily="34" charset="0"/>
+                <a:ea typeface="Be Vietnam Pro" pitchFamily="34" charset="-122"/>
+                <a:cs typeface="Be Vietnam Pro" pitchFamily="34" charset="-120"/>
+              </a:rPr>
+              <a:t> mạng</a:t>
+            </a:r>
+            <a:r>
+              <a:rPr lang="en-US" sz="1950" dirty="0" spc="-3" kern="0">
+                <a:solidFill>
+                  <a:srgbClr val="6B6A66"/>
+                </a:solidFill>
+                <a:latin typeface="Be Vietnam Pro" pitchFamily="34" charset="0"/>
+                <a:ea typeface="Be Vietnam Pro" pitchFamily="34" charset="-122"/>
+                <a:cs typeface="Be Vietnam Pro" pitchFamily="34" charset="-120"/>
+              </a:rPr>
+              <a:t> (Bitcoin,</a:t>
+            </a:r>
+            <a:r>
+              <a:rPr lang="en-US" sz="1950" dirty="0" spc="-6" kern="0">
+                <a:solidFill>
+                  <a:srgbClr val="6B6A66"/>
+                </a:solidFill>
+                <a:latin typeface="Be Vietnam Pro" pitchFamily="34" charset="0"/>
+                <a:ea typeface="Be Vietnam Pro" pitchFamily="34" charset="-122"/>
+                <a:cs typeface="Be Vietnam Pro" pitchFamily="34" charset="-120"/>
+              </a:rPr>
+              <a:t> Ethereum)</a:t>
             </a:r>
             <a:r>
               <a:rPr lang="en-US" sz="1950" dirty="0" spc="-1" kern="0">
@@ -7723,10 +7822,76 @@
                 <a:ea typeface="Be Vietnam Pro" pitchFamily="34" charset="-122"/>
                 <a:cs typeface="Be Vietnam Pro" pitchFamily="34" charset="-120"/>
               </a:rPr>
+              <a:t> là</a:t>
+            </a:r>
+            <a:r>
+              <a:rPr lang="en-US" sz="1950" dirty="0" spc="-3" kern="0">
+                <a:solidFill>
+                  <a:srgbClr val="6B6A66"/>
+                </a:solidFill>
+                <a:latin typeface="Be Vietnam Pro" pitchFamily="34" charset="0"/>
+                <a:ea typeface="Be Vietnam Pro" pitchFamily="34" charset="-122"/>
+                <a:cs typeface="Be Vietnam Pro" pitchFamily="34" charset="-120"/>
+              </a:rPr>
+              <a:t> khác</a:t>
+            </a:r>
+            <a:r>
+              <a:rPr lang="en-US" sz="1950" dirty="0" spc="-4" kern="0">
+                <a:solidFill>
+                  <a:srgbClr val="6B6A66"/>
+                </a:solidFill>
+                <a:latin typeface="Be Vietnam Pro" pitchFamily="34" charset="0"/>
+                <a:ea typeface="Be Vietnam Pro" pitchFamily="34" charset="-122"/>
+                <a:cs typeface="Be Vietnam Pro" pitchFamily="34" charset="-120"/>
+              </a:rPr>
+              <a:t> sổ,</a:t>
+            </a:r>
+            <a:r>
+              <a:rPr lang="en-US" sz="1950" dirty="0" spc="-3" kern="0">
+                <a:solidFill>
+                  <a:srgbClr val="6B6A66"/>
+                </a:solidFill>
+                <a:latin typeface="Be Vietnam Pro" pitchFamily="34" charset="0"/>
+                <a:ea typeface="Be Vietnam Pro" pitchFamily="34" charset="-122"/>
+                <a:cs typeface="Be Vietnam Pro" pitchFamily="34" charset="-120"/>
+              </a:rPr>
+              <a:t> khác</a:t>
+            </a:r>
+            <a:r>
+              <a:rPr lang="en-US" sz="1950" dirty="0" spc="21" kern="0">
+                <a:solidFill>
+                  <a:srgbClr val="6B6A66"/>
+                </a:solidFill>
+                <a:latin typeface="Be Vietnam Pro" pitchFamily="34" charset="0"/>
+                <a:ea typeface="Be Vietnam Pro" pitchFamily="34" charset="-122"/>
+                <a:cs typeface="Be Vietnam Pro" pitchFamily="34" charset="-120"/>
+              </a:rPr>
+              <a:t> địa</a:t>
+            </a:r>
+            <a:r>
+              <a:rPr lang="en-US" sz="1950" dirty="0" spc="-2" kern="0">
+                <a:solidFill>
+                  <a:srgbClr val="6B6A66"/>
+                </a:solidFill>
+                <a:latin typeface="Be Vietnam Pro" pitchFamily="34" charset="0"/>
+                <a:ea typeface="Be Vietnam Pro" pitchFamily="34" charset="-122"/>
+                <a:cs typeface="Be Vietnam Pro" pitchFamily="34" charset="-120"/>
+              </a:rPr>
+              <a:t> chỉ. Gộp</a:t>
+            </a:r>
+            <a:r>
+              <a:rPr lang="en-US" sz="1950" dirty="0" spc="-1" kern="0">
+                <a:solidFill>
+                  <a:srgbClr val="6B6A66"/>
+                </a:solidFill>
+                <a:latin typeface="Be Vietnam Pro" pitchFamily="34" charset="0"/>
+                <a:ea typeface="Be Vietnam Pro" pitchFamily="34" charset="-122"/>
+                <a:cs typeface="Be Vietnam Pro" pitchFamily="34" charset="-120"/>
+              </a:rPr>
               <a:t> ví</a:t>
             </a:r>
             <a:r>
-              <a:rPr lang="en-US" sz="1950" dirty="0" spc="2" kern="0">
+              <a:rPr lang="en-US" sz="1950" dirty="0" spc="-9" kern="0">
                 <a:solidFill>
                   <a:srgbClr val="6B6A66"/>
                 </a:solidFill>
@@ -7734,10 +7899,10 @@
                 <a:ea typeface="Be Vietnam Pro" pitchFamily="34" charset="-122"/>
                 <a:cs typeface="Be Vietnam Pro" pitchFamily="34" charset="-120"/>
               </a:rPr>
-              <a:t> nhiều</a:t>
-            </a:r>
-            <a:r>
-              <a:rPr lang="en-US" sz="1950" dirty="0" spc="-6" kern="0">
+              <a:t> toàn</a:t>
+            </a:r>
+            <a:r>
+              <a:rPr lang="en-US" sz="1950" dirty="0" spc="-2" kern="0">
                 <a:solidFill>
                   <a:srgbClr val="6B6A66"/>
                 </a:solidFill>
@@ -7745,7 +7910,7 @@
                 <a:ea typeface="Be Vietnam Pro" pitchFamily="34" charset="-122"/>
                 <a:cs typeface="Be Vietnam Pro" pitchFamily="34" charset="-120"/>
               </a:rPr>
-              <a:t> ngân</a:t>
+              <a:t> cầu:</a:t>
             </a:r>
             <a:r>
               <a:rPr lang="en-US" sz="1950" dirty="0" spc="1" kern="0">
@@ -7756,98 +7921,21 @@
                 <a:ea typeface="Be Vietnam Pro" pitchFamily="34" charset="-122"/>
                 <a:cs typeface="Be Vietnam Pro" pitchFamily="34" charset="-120"/>
               </a:rPr>
-              <a:t> hàng</a:t>
+              <a:t> nhận</a:t>
+            </a:r>
+            <a:r>
+              <a:rPr lang="en-US" sz="1950" dirty="0" spc="17" kern="0">
+                <a:solidFill>
+                  <a:srgbClr val="6B6A66"/>
+                </a:solidFill>
+                <a:latin typeface="Be Vietnam Pro" pitchFamily="34" charset="0"/>
+                <a:ea typeface="Be Vietnam Pro" pitchFamily="34" charset="-122"/>
+                <a:cs typeface="Be Vietnam Pro" pitchFamily="34" charset="-120"/>
+              </a:rPr>
+              <a:t> định</a:t>
             </a:r>
             <a:r>
               <a:rPr lang="en-US" sz="1950" dirty="0" spc="-1" kern="0">
-                <a:solidFill>
-                  <a:srgbClr val="6B6A66"/>
-                </a:solidFill>
-                <a:latin typeface="Be Vietnam Pro" pitchFamily="34" charset="0"/>
-                <a:ea typeface="Be Vietnam Pro" pitchFamily="34" charset="-122"/>
-                <a:cs typeface="Be Vietnam Pro" pitchFamily="34" charset="-120"/>
-              </a:rPr>
-              <a:t> thành</a:t>
-            </a:r>
-            <a:r>
-              <a:rPr lang="en-US" sz="1950" dirty="0" spc="-5" kern="0">
-                <a:solidFill>
-                  <a:srgbClr val="6B6A66"/>
-                </a:solidFill>
-                <a:latin typeface="Be Vietnam Pro" pitchFamily="34" charset="0"/>
-                <a:ea typeface="Be Vietnam Pro" pitchFamily="34" charset="-122"/>
-                <a:cs typeface="Be Vietnam Pro" pitchFamily="34" charset="-120"/>
-              </a:rPr>
-              <a:t> một</a:t>
-            </a:r>
-            <a:r>
-              <a:rPr lang="en-US" sz="1950" dirty="0" spc="-2" kern="0">
-                <a:solidFill>
-                  <a:srgbClr val="6B6A66"/>
-                </a:solidFill>
-                <a:latin typeface="Be Vietnam Pro" pitchFamily="34" charset="0"/>
-                <a:ea typeface="Be Vietnam Pro" pitchFamily="34" charset="-122"/>
-                <a:cs typeface="Be Vietnam Pro" pitchFamily="34" charset="-120"/>
-              </a:rPr>
-              <a:t> dịch</a:t>
-            </a:r>
-            <a:r>
-              <a:rPr lang="en-US" sz="1950" dirty="0" spc="-1" kern="0">
-                <a:solidFill>
-                  <a:srgbClr val="6B6A66"/>
-                </a:solidFill>
-                <a:latin typeface="Be Vietnam Pro" pitchFamily="34" charset="0"/>
-                <a:ea typeface="Be Vietnam Pro" pitchFamily="34" charset="-122"/>
-                <a:cs typeface="Be Vietnam Pro" pitchFamily="34" charset="-120"/>
-              </a:rPr>
-              <a:t> vụ</a:t>
-            </a:r>
-            <a:r>
-              <a:rPr lang="en-US" sz="1950" dirty="0" spc="-9" kern="0">
-                <a:solidFill>
-                  <a:srgbClr val="6B6A66"/>
-                </a:solidFill>
-                <a:latin typeface="Be Vietnam Pro" pitchFamily="34" charset="0"/>
-                <a:ea typeface="Be Vietnam Pro" pitchFamily="34" charset="-122"/>
-                <a:cs typeface="Be Vietnam Pro" pitchFamily="34" charset="-120"/>
-              </a:rPr>
-              <a:t> toàn</a:t>
-            </a:r>
-            <a:r>
-              <a:rPr lang="en-US" sz="1950" dirty="0" spc="-2" kern="0">
-                <a:solidFill>
-                  <a:srgbClr val="6B6A66"/>
-                </a:solidFill>
-                <a:latin typeface="Be Vietnam Pro" pitchFamily="34" charset="0"/>
-                <a:ea typeface="Be Vietnam Pro" pitchFamily="34" charset="-122"/>
-                <a:cs typeface="Be Vietnam Pro" pitchFamily="34" charset="-120"/>
-              </a:rPr>
-              <a:t> cầu:</a:t>
-            </a:r>
-            <a:r>
-              <a:rPr lang="en-US" sz="1950" dirty="0" spc="1" kern="0">
-                <a:solidFill>
-                  <a:srgbClr val="6B6A66"/>
-                </a:solidFill>
-                <a:latin typeface="Be Vietnam Pro" pitchFamily="34" charset="0"/>
-                <a:ea typeface="Be Vietnam Pro" pitchFamily="34" charset="-122"/>
-                <a:cs typeface="Be Vietnam Pro" pitchFamily="34" charset="-120"/>
-              </a:rPr>
-              <a:t> nhận</a:t>
-            </a:r>
-            <a:r>
-              <a:rPr lang="en-US" sz="1950" dirty="0" spc="17" kern="0">
-                <a:solidFill>
-                  <a:srgbClr val="6B6A66"/>
-                </a:solidFill>
-                <a:latin typeface="Be Vietnam Pro" pitchFamily="34" charset="0"/>
-                <a:ea typeface="Be Vietnam Pro" pitchFamily="34" charset="-122"/>
-                <a:cs typeface="Be Vietnam Pro" pitchFamily="34" charset="-120"/>
-              </a:rPr>
-              <a:t> định</a:t>
-            </a:r>
-            <a:r>
-              <a:rPr lang="en-US" sz="1950" dirty="0" spc="0" kern="0">
                 <a:solidFill>
                   <a:srgbClr val="6B6A66"/>
                 </a:solidFill>
@@ -10186,7 +10274,7 @@
               <a:t> sao</a:t>
             </a:r>
             <a:r>
-              <a:rPr lang="en-US" sz="2850" dirty="0" spc="-10" kern="0">
+              <a:rPr lang="en-US" sz="2850" dirty="0" spc="-1" kern="0">
                 <a:solidFill>
                   <a:srgbClr val="14161C"/>
                 </a:solidFill>
@@ -10194,6 +10282,28 @@
                 <a:ea typeface="Be Vietnam Pro" pitchFamily="34" charset="-122"/>
                 <a:cs typeface="Be Vietnam Pro" pitchFamily="34" charset="-120"/>
               </a:rPr>
+              <a:t> có</a:t>
+            </a:r>
+            <a:r>
+              <a:rPr lang="en-US" sz="2850" dirty="0" spc="0" kern="0">
+                <a:solidFill>
+                  <a:srgbClr val="14161C"/>
+                </a:solidFill>
+                <a:latin typeface="Be Vietnam Pro" pitchFamily="34" charset="0"/>
+                <a:ea typeface="Be Vietnam Pro" pitchFamily="34" charset="-122"/>
+                <a:cs typeface="Be Vietnam Pro" pitchFamily="34" charset="-120"/>
+              </a:rPr>
+              <a:t> lúc</a:t>
+            </a:r>
+            <a:r>
+              <a:rPr lang="en-US" sz="2850" dirty="0" spc="-9" kern="0">
+                <a:solidFill>
+                  <a:srgbClr val="14161C"/>
+                </a:solidFill>
+                <a:latin typeface="Be Vietnam Pro" pitchFamily="34" charset="0"/>
+                <a:ea typeface="Be Vietnam Pro" pitchFamily="34" charset="-122"/>
+                <a:cs typeface="Be Vietnam Pro" pitchFamily="34" charset="-120"/>
+              </a:rPr>
               <a:t> sổ</a:t>
             </a:r>
             <a:r>
@@ -10219,6 +10329,17 @@
               <a:t> đổi</a:t>
             </a:r>
             <a:r>
+              <a:rPr lang="en-US" sz="2850" dirty="0" spc="-1" kern="0">
+                <a:solidFill>
+                  <a:srgbClr val="14161C"/>
+                </a:solidFill>
+                <a:latin typeface="Be Vietnam Pro" pitchFamily="34" charset="0"/>
+                <a:ea typeface="Be Vietnam Pro" pitchFamily="34" charset="-122"/>
+                <a:cs typeface="Be Vietnam Pro" pitchFamily="34" charset="-120"/>
+              </a:rPr>
+              <a:t> mà</a:t>
+            </a:r>
+            <a:r>
               <a:rPr lang="en-US" sz="2850" dirty="0" spc="0" kern="0">
                 <a:solidFill>
                   <a:srgbClr val="14161C"/>
@@ -10227,10 +10348,10 @@
                 <a:ea typeface="Be Vietnam Pro" pitchFamily="34" charset="-122"/>
                 <a:cs typeface="Be Vietnam Pro" pitchFamily="34" charset="-120"/>
               </a:rPr>
-              <a:t> mà</a:t>
-            </a:r>
-            <a:r>
-              <a:rPr lang="en-US" sz="2850" dirty="0" spc="-1" kern="0">
+              <a:t> tiền</a:t>
+            </a:r>
+            <a:r>
+              <a:rPr lang="en-US" sz="2850" dirty="0" spc="-13" kern="0">
                 <a:solidFill>
                   <a:srgbClr val="14161C"/>
                 </a:solidFill>
@@ -10238,10 +10359,10 @@
                 <a:ea typeface="Be Vietnam Pro" pitchFamily="34" charset="-122"/>
                 <a:cs typeface="Be Vietnam Pro" pitchFamily="34" charset="-120"/>
               </a:rPr>
-              <a:t> tiền</a:t>
-            </a:r>
-            <a:r>
-              <a:rPr lang="en-US" sz="2850" dirty="0" spc="-13" kern="0">
+              <a:t> thật</a:t>
+            </a:r>
+            <a:r>
+              <a:rPr lang="en-US" sz="2850" dirty="0" spc="10" kern="0">
                 <a:solidFill>
                   <a:srgbClr val="14161C"/>
                 </a:solidFill>
@@ -10249,7 +10370,7 @@
                 <a:ea typeface="Be Vietnam Pro" pitchFamily="34" charset="-122"/>
                 <a:cs typeface="Be Vietnam Pro" pitchFamily="34" charset="-120"/>
               </a:rPr>
-              <a:t> thật</a:t>
+              <a:t> chưa</a:t>
             </a:r>
             <a:r>
               <a:rPr lang="en-US" sz="2850" dirty="0" spc="11" kern="0">
@@ -10260,7 +10381,7 @@
                 <a:ea typeface="Be Vietnam Pro" pitchFamily="34" charset="-122"/>
                 <a:cs typeface="Be Vietnam Pro" pitchFamily="34" charset="-120"/>
               </a:rPr>
-              <a:t> chưa đổi?</a:t>
+              <a:t> đổi?</a:t>
             </a:r>
             <a:endParaRPr lang="en-US" sz="2850" dirty="0"/>
           </a:p>
@@ -10356,12 +10477,12 @@
           <a:ln/>
         </p:spPr>
         <p:txBody>
-          <a:bodyPr wrap="square" lIns="0" tIns="14573" rIns="0" bIns="-14573" rtlCol="0" anchor="t"/>
+          <a:bodyPr wrap="square" lIns="0" tIns="13764" rIns="0" bIns="-13764" rtlCol="0" anchor="t"/>
           <a:lstStyle/>
           <a:p>
-            <a:pPr algn="l" marL="342900" indent="-244981">
+            <a:pPr algn="l" marL="323850" indent="-231371">
               <a:lnSpc>
-                <a:spcPts val="3510"/>
+                <a:spcPts val="3315"/>
               </a:lnSpc>
               <a:spcAft>
                 <a:spcPts val="1500"/>
@@ -10371,7 +10492,7 @@
               <a:buChar char="•"/>
             </a:pPr>
             <a:r>
-              <a:rPr lang="en-US" sz="2700" dirty="0" spc="-14" kern="0">
+              <a:rPr lang="en-US" sz="2550" dirty="0" spc="-11" kern="0">
                 <a:solidFill>
                   <a:srgbClr val="F3EEE3"/>
                 </a:solidFill>
@@ -10382,29 +10503,18 @@
               <a:t>Ngân</a:t>
             </a:r>
             <a:r>
-              <a:rPr lang="en-US" sz="2700" dirty="0" spc="-2" kern="0">
-                <a:solidFill>
-                  <a:srgbClr val="F3EEE3"/>
-                </a:solidFill>
-                <a:latin typeface="Be Vietnam Pro" pitchFamily="34" charset="0"/>
-                <a:ea typeface="Be Vietnam Pro" pitchFamily="34" charset="-122"/>
-                <a:cs typeface="Be Vietnam Pro" pitchFamily="34" charset="-120"/>
-              </a:rPr>
-              <a:t> hàng:</a:t>
-            </a:r>
-            <a:r>
-              <a:rPr lang="en-US" sz="2700" dirty="0" spc="-1" kern="0">
-                <a:solidFill>
-                  <a:srgbClr val="F3EEE3"/>
-                </a:solidFill>
-                <a:latin typeface="Be Vietnam Pro" pitchFamily="34" charset="0"/>
-                <a:ea typeface="Be Vietnam Pro" pitchFamily="34" charset="-122"/>
-                <a:cs typeface="Be Vietnam Pro" pitchFamily="34" charset="-120"/>
-              </a:rPr>
-              <a:t> chỉ</a:t>
-            </a:r>
-            <a:r>
-              <a:rPr lang="en-US" sz="2700" dirty="0" spc="-13" kern="0">
+              <a:rPr lang="en-US" sz="2550" dirty="0" spc="1" kern="0">
+                <a:solidFill>
+                  <a:srgbClr val="F3EEE3"/>
+                </a:solidFill>
+                <a:latin typeface="Be Vietnam Pro" pitchFamily="34" charset="0"/>
+                <a:ea typeface="Be Vietnam Pro" pitchFamily="34" charset="-122"/>
+                <a:cs typeface="Be Vietnam Pro" pitchFamily="34" charset="-120"/>
+              </a:rPr>
+              <a:t> hàng: chỉ</a:t>
+            </a:r>
+            <a:r>
+              <a:rPr lang="en-US" sz="2550" dirty="0" spc="-10" kern="0">
                 <a:solidFill>
                   <a:srgbClr val="F3EEE3"/>
                 </a:solidFill>
@@ -10415,7 +10525,7 @@
               <a:t> ngân</a:t>
             </a:r>
             <a:r>
-              <a:rPr lang="en-US" sz="2700" dirty="0" spc="-2" kern="0">
+              <a:rPr lang="en-US" sz="2550" dirty="0" spc="0" kern="0">
                 <a:solidFill>
                   <a:srgbClr val="F3EEE3"/>
                 </a:solidFill>
@@ -10426,7 +10536,7 @@
               <a:t> hàng</a:t>
             </a:r>
             <a:r>
-              <a:rPr lang="en-US" sz="2700" dirty="0" spc="16" kern="0">
+              <a:rPr lang="en-US" sz="2550" dirty="0" spc="17" kern="0">
                 <a:solidFill>
                   <a:srgbClr val="F3EEE3"/>
                 </a:solidFill>
@@ -10437,7 +10547,7 @@
               <a:t> đó</a:t>
             </a:r>
             <a:r>
-              <a:rPr lang="en-US" sz="2700" dirty="0" spc="-6" kern="0">
+              <a:rPr lang="en-US" sz="2550" dirty="0" spc="-4" kern="0">
                 <a:solidFill>
                   <a:srgbClr val="F3EEE3"/>
                 </a:solidFill>
@@ -10448,7 +10558,7 @@
               <a:t> biết</a:t>
             </a:r>
             <a:r>
-              <a:rPr lang="en-US" sz="2700" dirty="0" spc="-13" kern="0">
+              <a:rPr lang="en-US" sz="2550" dirty="0" spc="-11" kern="0">
                 <a:solidFill>
                   <a:srgbClr val="F3EEE3"/>
                 </a:solidFill>
@@ -10459,7 +10569,7 @@
               <a:t> số</a:t>
             </a:r>
             <a:r>
-              <a:rPr lang="en-US" sz="2700" dirty="0" spc="-1" kern="0">
+              <a:rPr lang="en-US" sz="2550" dirty="0" spc="0" kern="0">
                 <a:solidFill>
                   <a:srgbClr val="F3EEE3"/>
                 </a:solidFill>
@@ -10469,12 +10579,12 @@
               </a:rPr>
               <a:t> dư.</a:t>
             </a:r>
-            <a:endParaRPr lang="en-US" sz="2700" dirty="0"/>
+            <a:endParaRPr lang="en-US" sz="2550" dirty="0"/>
           </a:p>
           <a:p>
-            <a:pPr algn="l" marL="342900" indent="-244981">
+            <a:pPr algn="l" marL="323850" indent="-231371">
               <a:lnSpc>
-                <a:spcPts val="3510"/>
+                <a:spcPts val="3315"/>
               </a:lnSpc>
               <a:spcAft>
                 <a:spcPts val="1500"/>
@@ -10484,18 +10594,40 @@
               <a:buChar char="•"/>
             </a:pPr>
             <a:r>
-              <a:rPr lang="en-US" sz="2700" dirty="0" spc="0" kern="0">
-                <a:solidFill>
-                  <a:srgbClr val="F3EEE3"/>
-                </a:solidFill>
-                <a:latin typeface="Be Vietnam Pro" pitchFamily="34" charset="0"/>
-                <a:ea typeface="Be Vietnam Pro" pitchFamily="34" charset="-122"/>
-                <a:cs typeface="Be Vietnam Pro" pitchFamily="34" charset="-120"/>
-              </a:rPr>
-              <a:t>Sổ</a:t>
-            </a:r>
-            <a:r>
-              <a:rPr lang="en-US" sz="2700" dirty="0" spc="12" kern="0">
+              <a:rPr lang="en-US" sz="2550" dirty="0" spc="0" kern="0">
+                <a:solidFill>
+                  <a:srgbClr val="F3EEE3"/>
+                </a:solidFill>
+                <a:latin typeface="Be Vietnam Pro" pitchFamily="34" charset="0"/>
+                <a:ea typeface="Be Vietnam Pro" pitchFamily="34" charset="-122"/>
+                <a:cs typeface="Be Vietnam Pro" pitchFamily="34" charset="-120"/>
+              </a:rPr>
+              <a:t>Mô hình</a:t>
+            </a:r>
+            <a:r>
+              <a:rPr lang="en-US" sz="2550" dirty="0" spc="-9" kern="0">
+                <a:solidFill>
+                  <a:srgbClr val="F3EEE3"/>
+                </a:solidFill>
+                <a:latin typeface="Be Vietnam Pro" pitchFamily="34" charset="0"/>
+                <a:ea typeface="Be Vietnam Pro" pitchFamily="34" charset="-122"/>
+                <a:cs typeface="Be Vietnam Pro" pitchFamily="34" charset="-120"/>
+              </a:rPr>
+              <a:t> gọn:</a:t>
+            </a:r>
+            <a:r>
+              <a:rPr lang="en-US" sz="2550" dirty="0" spc="-11" kern="0">
+                <a:solidFill>
+                  <a:srgbClr val="F3EEE3"/>
+                </a:solidFill>
+                <a:latin typeface="Be Vietnam Pro" pitchFamily="34" charset="0"/>
+                <a:ea typeface="Be Vietnam Pro" pitchFamily="34" charset="-122"/>
+                <a:cs typeface="Be Vietnam Pro" pitchFamily="34" charset="-120"/>
+              </a:rPr>
+              <a:t> sổ</a:t>
+            </a:r>
+            <a:r>
+              <a:rPr lang="en-US" sz="2550" dirty="0" spc="12" kern="0">
                 <a:solidFill>
                   <a:srgbClr val="F3EEE3"/>
                 </a:solidFill>
@@ -10506,7 +10638,7 @@
               <a:t> đổi</a:t>
             </a:r>
             <a:r>
-              <a:rPr lang="en-US" sz="2700" dirty="0" spc="-17" kern="0">
+              <a:rPr lang="en-US" sz="2550" dirty="0" spc="-15" kern="0">
                 <a:solidFill>
                   <a:srgbClr val="F3EEE3"/>
                 </a:solidFill>
@@ -10517,7 +10649,7 @@
               <a:t> ngay,</a:t>
             </a:r>
             <a:r>
-              <a:rPr lang="en-US" sz="2700" dirty="0" spc="-1" kern="0">
+              <a:rPr lang="en-US" sz="2550" dirty="0" spc="0" kern="0">
                 <a:solidFill>
                   <a:srgbClr val="F3EEE3"/>
                 </a:solidFill>
@@ -10528,7 +10660,7 @@
               <a:t> tiền</a:t>
             </a:r>
             <a:r>
-              <a:rPr lang="en-US" sz="2700" dirty="0" spc="-10" kern="0">
+              <a:rPr lang="en-US" sz="2550" dirty="0" spc="-8" kern="0">
                 <a:solidFill>
                   <a:srgbClr val="F3EEE3"/>
                 </a:solidFill>
@@ -10539,51 +10671,7 @@
               <a:t> thật</a:t>
             </a:r>
             <a:r>
-              <a:rPr lang="en-US" sz="2700" dirty="0" spc="-9" kern="0">
-                <a:solidFill>
-                  <a:srgbClr val="F3EEE3"/>
-                </a:solidFill>
-                <a:latin typeface="Be Vietnam Pro" pitchFamily="34" charset="0"/>
-                <a:ea typeface="Be Vietnam Pro" pitchFamily="34" charset="-122"/>
-                <a:cs typeface="Be Vietnam Pro" pitchFamily="34" charset="-120"/>
-              </a:rPr>
-              <a:t> sau</a:t>
-            </a:r>
-            <a:r>
-              <a:rPr lang="en-US" sz="2700" dirty="0" spc="-2" kern="0">
-                <a:solidFill>
-                  <a:srgbClr val="F3EEE3"/>
-                </a:solidFill>
-                <a:latin typeface="Be Vietnam Pro" pitchFamily="34" charset="0"/>
-                <a:ea typeface="Be Vietnam Pro" pitchFamily="34" charset="-122"/>
-                <a:cs typeface="Be Vietnam Pro" pitchFamily="34" charset="-120"/>
-              </a:rPr>
-              <a:t> (mô</a:t>
-            </a:r>
-            <a:r>
-              <a:rPr lang="en-US" sz="2700" dirty="0" spc="-3" kern="0">
-                <a:solidFill>
-                  <a:srgbClr val="F3EEE3"/>
-                </a:solidFill>
-                <a:latin typeface="Be Vietnam Pro" pitchFamily="34" charset="0"/>
-                <a:ea typeface="Be Vietnam Pro" pitchFamily="34" charset="-122"/>
-                <a:cs typeface="Be Vietnam Pro" pitchFamily="34" charset="-120"/>
-              </a:rPr>
-              <a:t> hình</a:t>
-            </a:r>
-            <a:r>
-              <a:rPr lang="en-US" sz="2700" dirty="0" spc="-13" kern="0">
-                <a:solidFill>
-                  <a:srgbClr val="F3EEE3"/>
-                </a:solidFill>
-                <a:latin typeface="Be Vietnam Pro" pitchFamily="34" charset="0"/>
-                <a:ea typeface="Be Vietnam Pro" pitchFamily="34" charset="-122"/>
-                <a:cs typeface="Be Vietnam Pro" pitchFamily="34" charset="-120"/>
-              </a:rPr>
-              <a:t> gọn:</a:t>
-            </a:r>
-            <a:r>
-              <a:rPr lang="en-US" sz="2700" dirty="0" spc="0" kern="0">
+              <a:rPr lang="en-US" sz="2550" dirty="0" spc="0" kern="0">
                 <a:solidFill>
                   <a:srgbClr val="F3EEE3"/>
                 </a:solidFill>
@@ -10594,40 +10682,142 @@
               <a:t> cuối</a:t>
             </a:r>
             <a:r>
-              <a:rPr lang="en-US" sz="2700" dirty="0" spc="-15" kern="0">
-                <a:solidFill>
-                  <a:srgbClr val="F3EEE3"/>
-                </a:solidFill>
-                <a:latin typeface="Be Vietnam Pro" pitchFamily="34" charset="0"/>
-                <a:ea typeface="Be Vietnam Pro" pitchFamily="34" charset="-122"/>
-                <a:cs typeface="Be Vietnam Pro" pitchFamily="34" charset="-120"/>
-              </a:rPr>
-              <a:t> ngày).</a:t>
-            </a:r>
-            <a:endParaRPr lang="en-US" sz="2700" dirty="0"/>
+              <a:rPr lang="en-US" sz="2550" dirty="0" spc="-14" kern="0">
+                <a:solidFill>
+                  <a:srgbClr val="F3EEE3"/>
+                </a:solidFill>
+                <a:latin typeface="Be Vietnam Pro" pitchFamily="34" charset="0"/>
+                <a:ea typeface="Be Vietnam Pro" pitchFamily="34" charset="-122"/>
+                <a:cs typeface="Be Vietnam Pro" pitchFamily="34" charset="-120"/>
+              </a:rPr>
+              <a:t> ngày.</a:t>
+            </a:r>
+            <a:endParaRPr lang="en-US" sz="2550" dirty="0"/>
           </a:p>
           <a:p>
-            <a:pPr algn="l" marL="342900" indent="-244981">
+            <a:pPr algn="l" marL="323850" indent="-231371">
               <a:lnSpc>
-                <a:spcPts val="3510"/>
+                <a:spcPts val="3315"/>
+              </a:lnSpc>
+              <a:spcAft>
+                <a:spcPts val="1500"/>
+              </a:spcAft>
+              <a:buSzPct val="100000"/>
+              <a:buFont typeface="Arial"/>
+              <a:buChar char="•"/>
+            </a:pPr>
+            <a:r>
+              <a:rPr lang="en-US" sz="2550" dirty="0" spc="7" kern="0">
+                <a:solidFill>
+                  <a:srgbClr val="F3EEE3"/>
+                </a:solidFill>
+                <a:latin typeface="Be Vietnam Pro" pitchFamily="34" charset="0"/>
+                <a:ea typeface="Be Vietnam Pro" pitchFamily="34" charset="-122"/>
+                <a:cs typeface="Be Vietnam Pro" pitchFamily="34" charset="-120"/>
+              </a:rPr>
+              <a:t>Thực</a:t>
+            </a:r>
+            <a:r>
+              <a:rPr lang="en-US" sz="2550" dirty="0" spc="-15" kern="0">
+                <a:solidFill>
+                  <a:srgbClr val="F3EEE3"/>
+                </a:solidFill>
+                <a:latin typeface="Be Vietnam Pro" pitchFamily="34" charset="0"/>
+                <a:ea typeface="Be Vietnam Pro" pitchFamily="34" charset="-122"/>
+                <a:cs typeface="Be Vietnam Pro" pitchFamily="34" charset="-120"/>
+              </a:rPr>
+              <a:t> tế</a:t>
+            </a:r>
+            <a:r>
+              <a:rPr lang="en-US" sz="2550" dirty="0" spc="-1" kern="0">
+                <a:solidFill>
+                  <a:srgbClr val="F3EEE3"/>
+                </a:solidFill>
+                <a:latin typeface="Be Vietnam Pro" pitchFamily="34" charset="0"/>
+                <a:ea typeface="Be Vietnam Pro" pitchFamily="34" charset="-122"/>
+                <a:cs typeface="Be Vietnam Pro" pitchFamily="34" charset="-120"/>
+              </a:rPr>
+              <a:t> tùy</a:t>
+            </a:r>
+            <a:r>
+              <a:rPr lang="en-US" sz="2550" dirty="0" spc="0" kern="0">
+                <a:solidFill>
+                  <a:srgbClr val="F3EEE3"/>
+                </a:solidFill>
+                <a:latin typeface="Be Vietnam Pro" pitchFamily="34" charset="0"/>
+                <a:ea typeface="Be Vietnam Pro" pitchFamily="34" charset="-122"/>
+                <a:cs typeface="Be Vietnam Pro" pitchFamily="34" charset="-120"/>
+              </a:rPr>
+              <a:t> hệ</a:t>
+            </a:r>
+            <a:r>
+              <a:rPr lang="en-US" sz="2550" dirty="0" spc="1" kern="0">
+                <a:solidFill>
+                  <a:srgbClr val="F3EEE3"/>
+                </a:solidFill>
+                <a:latin typeface="Be Vietnam Pro" pitchFamily="34" charset="0"/>
+                <a:ea typeface="Be Vietnam Pro" pitchFamily="34" charset="-122"/>
+                <a:cs typeface="Be Vietnam Pro" pitchFamily="34" charset="-120"/>
+              </a:rPr>
+              <a:t> thống</a:t>
+            </a:r>
+            <a:r>
+              <a:rPr lang="en-US" sz="2550" dirty="0" spc="-12" kern="0">
+                <a:solidFill>
+                  <a:srgbClr val="F3EEE3"/>
+                </a:solidFill>
+                <a:latin typeface="Be Vietnam Pro" pitchFamily="34" charset="0"/>
+                <a:ea typeface="Be Vietnam Pro" pitchFamily="34" charset="-122"/>
+                <a:cs typeface="Be Vietnam Pro" pitchFamily="34" charset="-120"/>
+              </a:rPr>
+              <a:t> chuyển</a:t>
+            </a:r>
+            <a:r>
+              <a:rPr lang="en-US" sz="2550" dirty="0" spc="1" kern="0">
+                <a:solidFill>
+                  <a:srgbClr val="F3EEE3"/>
+                </a:solidFill>
+                <a:latin typeface="Be Vietnam Pro" pitchFamily="34" charset="0"/>
+                <a:ea typeface="Be Vietnam Pro" pitchFamily="34" charset="-122"/>
+                <a:cs typeface="Be Vietnam Pro" pitchFamily="34" charset="-120"/>
+              </a:rPr>
+              <a:t> tiền.</a:t>
+            </a:r>
+            <a:endParaRPr lang="en-US" sz="2550" dirty="0"/>
+          </a:p>
+          <a:p>
+            <a:pPr algn="l" marL="323850" indent="-231371">
+              <a:lnSpc>
+                <a:spcPts val="3315"/>
               </a:lnSpc>
               <a:buSzPct val="100000"/>
               <a:buFont typeface="Arial"/>
               <a:buChar char="•"/>
             </a:pPr>
             <a:r>
-              <a:rPr lang="en-US" sz="2700" dirty="0" spc="-13" kern="0">
-                <a:solidFill>
-                  <a:srgbClr val="F3EEE3"/>
-                </a:solidFill>
-                <a:latin typeface="Be Vietnam Pro" pitchFamily="34" charset="0"/>
-                <a:ea typeface="Be Vietnam Pro" pitchFamily="34" charset="-122"/>
-                <a:cs typeface="Be Vietnam Pro" pitchFamily="34" charset="-120"/>
-              </a:rPr>
-              <a:t>Blockchain: số</a:t>
-            </a:r>
-            <a:r>
-              <a:rPr lang="en-US" sz="2700" dirty="0" spc="0" kern="0">
+              <a:rPr lang="en-US" sz="2550" dirty="0" spc="-11" kern="0">
+                <a:solidFill>
+                  <a:srgbClr val="F3EEE3"/>
+                </a:solidFill>
+                <a:latin typeface="Be Vietnam Pro" pitchFamily="34" charset="0"/>
+                <a:ea typeface="Be Vietnam Pro" pitchFamily="34" charset="-122"/>
+                <a:cs typeface="Be Vietnam Pro" pitchFamily="34" charset="-120"/>
+              </a:rPr>
+              <a:t>Blockchain:</a:t>
+            </a:r>
+            <a:r>
+              <a:rPr lang="en-US" sz="2550" dirty="0" spc="-9" kern="0">
+                <a:solidFill>
+                  <a:srgbClr val="F3EEE3"/>
+                </a:solidFill>
+                <a:latin typeface="Be Vietnam Pro" pitchFamily="34" charset="0"/>
+                <a:ea typeface="Be Vietnam Pro" pitchFamily="34" charset="-122"/>
+                <a:cs typeface="Be Vietnam Pro" pitchFamily="34" charset="-120"/>
+              </a:rPr>
+              <a:t> số</a:t>
+            </a:r>
+            <a:r>
+              <a:rPr lang="en-US" sz="2550" dirty="0" spc="-3" kern="0">
                 <a:solidFill>
                   <a:srgbClr val="F3EEE3"/>
                 </a:solidFill>
@@ -10638,7 +10828,7 @@
               <a:t> dư</a:t>
             </a:r>
             <a:r>
-              <a:rPr lang="en-US" sz="2700" dirty="0" spc="-2" kern="0">
+              <a:rPr lang="en-US" sz="2550" dirty="0" spc="1" kern="0">
                 <a:solidFill>
                   <a:srgbClr val="F3EEE3"/>
                 </a:solidFill>
@@ -10649,18 +10839,7 @@
               <a:t> nằm</a:t>
             </a:r>
             <a:r>
-              <a:rPr lang="en-US" sz="2700" dirty="0" spc="-22" kern="0">
-                <a:solidFill>
-                  <a:srgbClr val="F3EEE3"/>
-                </a:solidFill>
-                <a:latin typeface="Be Vietnam Pro" pitchFamily="34" charset="0"/>
-                <a:ea typeface="Be Vietnam Pro" pitchFamily="34" charset="-122"/>
-                <a:cs typeface="Be Vietnam Pro" pitchFamily="34" charset="-120"/>
-              </a:rPr>
-              <a:t> ngay</a:t>
-            </a:r>
-            <a:r>
-              <a:rPr lang="en-US" sz="2700" dirty="0" spc="-19" kern="0">
+              <a:rPr lang="en-US" sz="2550" dirty="0" spc="-17" kern="0">
                 <a:solidFill>
                   <a:srgbClr val="F3EEE3"/>
                 </a:solidFill>
@@ -10671,7 +10850,7 @@
               <a:t> trong</a:t>
             </a:r>
             <a:r>
-              <a:rPr lang="en-US" sz="2700" dirty="0" spc="-13" kern="0">
+              <a:rPr lang="en-US" sz="2550" dirty="0" spc="-9" kern="0">
                 <a:solidFill>
                   <a:srgbClr val="F3EEE3"/>
                 </a:solidFill>
@@ -10682,17 +10861,50 @@
               <a:t> sổ</a:t>
             </a:r>
             <a:r>
-              <a:rPr lang="en-US" sz="2700" dirty="0" spc="0" kern="0">
-                <a:solidFill>
-                  <a:srgbClr val="F3EEE3"/>
-                </a:solidFill>
-                <a:latin typeface="Be Vietnam Pro" pitchFamily="34" charset="0"/>
-                <a:ea typeface="Be Vietnam Pro" pitchFamily="34" charset="-122"/>
-                <a:cs typeface="Be Vietnam Pro" pitchFamily="34" charset="-120"/>
-              </a:rPr>
-              <a:t> cái chung.</a:t>
-            </a:r>
-            <a:endParaRPr lang="en-US" sz="2700" dirty="0"/>
+              <a:rPr lang="en-US" sz="2550" dirty="0" spc="0" kern="0">
+                <a:solidFill>
+                  <a:srgbClr val="F3EEE3"/>
+                </a:solidFill>
+                <a:latin typeface="Be Vietnam Pro" pitchFamily="34" charset="0"/>
+                <a:ea typeface="Be Vietnam Pro" pitchFamily="34" charset="-122"/>
+                <a:cs typeface="Be Vietnam Pro" pitchFamily="34" charset="-120"/>
+              </a:rPr>
+              <a:t> cái</a:t>
+            </a:r>
+            <a:r>
+              <a:rPr lang="en-US" sz="2550" dirty="0" spc="-2" kern="0">
+                <a:solidFill>
+                  <a:srgbClr val="F3EEE3"/>
+                </a:solidFill>
+                <a:latin typeface="Be Vietnam Pro" pitchFamily="34" charset="0"/>
+                <a:ea typeface="Be Vietnam Pro" pitchFamily="34" charset="-122"/>
+                <a:cs typeface="Be Vietnam Pro" pitchFamily="34" charset="-120"/>
+              </a:rPr>
+              <a:t> của</a:t>
+            </a:r>
+            <a:r>
+              <a:rPr lang="en-US" sz="2550" dirty="0" spc="1" kern="0">
+                <a:solidFill>
+                  <a:srgbClr val="F3EEE3"/>
+                </a:solidFill>
+                <a:latin typeface="Be Vietnam Pro" pitchFamily="34" charset="0"/>
+                <a:ea typeface="Be Vietnam Pro" pitchFamily="34" charset="-122"/>
+                <a:cs typeface="Be Vietnam Pro" pitchFamily="34" charset="-120"/>
+              </a:rPr>
+              <a:t> mạng</a:t>
+            </a:r>
+            <a:r>
+              <a:rPr lang="en-US" sz="2550" dirty="0" spc="14" kern="0">
+                <a:solidFill>
+                  <a:srgbClr val="F3EEE3"/>
+                </a:solidFill>
+                <a:latin typeface="Be Vietnam Pro" pitchFamily="34" charset="0"/>
+                <a:ea typeface="Be Vietnam Pro" pitchFamily="34" charset="-122"/>
+                <a:cs typeface="Be Vietnam Pro" pitchFamily="34" charset="-120"/>
+              </a:rPr>
+              <a:t> đó.</a:t>
+            </a:r>
+            <a:endParaRPr lang="en-US" sz="2550" dirty="0"/>
           </a:p>
         </p:txBody>
       </p:sp>
@@ -12945,29 +13157,29 @@
                 <a:ea typeface="Be Vietnam Pro" pitchFamily="34" charset="-122"/>
                 <a:cs typeface="Be Vietnam Pro" pitchFamily="34" charset="-120"/>
               </a:rPr>
-              <a:t> mã</a:t>
-            </a:r>
-            <a:r>
-              <a:rPr lang="en-US" sz="2250" dirty="0" spc="-3" kern="0">
-                <a:solidFill>
-                  <a:srgbClr val="F3EEE3"/>
-                </a:solidFill>
-                <a:latin typeface="Be Vietnam Pro" pitchFamily="34" charset="0"/>
-                <a:ea typeface="Be Vietnam Pro" pitchFamily="34" charset="-122"/>
-                <a:cs typeface="Be Vietnam Pro" pitchFamily="34" charset="-120"/>
-              </a:rPr>
-              <a:t> hóa,</a:t>
-            </a:r>
-            <a:r>
-              <a:rPr lang="en-US" sz="2250" dirty="0" spc="-7" kern="0">
-                <a:solidFill>
-                  <a:srgbClr val="F3EEE3"/>
-                </a:solidFill>
-                <a:latin typeface="Be Vietnam Pro" pitchFamily="34" charset="0"/>
-                <a:ea typeface="Be Vietnam Pro" pitchFamily="34" charset="-122"/>
-                <a:cs typeface="Be Vietnam Pro" pitchFamily="34" charset="-120"/>
-              </a:rPr>
-              <a:t> thay</a:t>
+              <a:t> mã hóa</a:t>
+            </a:r>
+            <a:r>
+              <a:rPr lang="en-US" sz="2250" dirty="0" spc="-18" kern="0">
+                <a:solidFill>
+                  <a:srgbClr val="F3EEE3"/>
+                </a:solidFill>
+                <a:latin typeface="Be Vietnam Pro" pitchFamily="34" charset="0"/>
+                <a:ea typeface="Be Vietnam Pro" pitchFamily="34" charset="-122"/>
+                <a:cs typeface="Be Vietnam Pro" pitchFamily="34" charset="-120"/>
+              </a:rPr>
+              <a:t> trên</a:t>
+            </a:r>
+            <a:r>
+              <a:rPr lang="en-US" sz="2250" dirty="0" spc="-4" kern="0">
+                <a:solidFill>
+                  <a:srgbClr val="F3EEE3"/>
+                </a:solidFill>
+                <a:latin typeface="Be Vietnam Pro" pitchFamily="34" charset="0"/>
+                <a:ea typeface="Be Vietnam Pro" pitchFamily="34" charset="-122"/>
+                <a:cs typeface="Be Vietnam Pro" pitchFamily="34" charset="-120"/>
+              </a:rPr>
+              <a:t> một</a:t>
             </a:r>
             <a:r>
               <a:rPr lang="en-US" sz="2250" dirty="0" spc="-1" kern="0">
@@ -12978,29 +13190,18 @@
                 <a:ea typeface="Be Vietnam Pro" pitchFamily="34" charset="-122"/>
                 <a:cs typeface="Be Vietnam Pro" pitchFamily="34" charset="-120"/>
               </a:rPr>
-              <a:t> nhiều</a:t>
-            </a:r>
-            <a:r>
-              <a:rPr lang="en-US" sz="2250" dirty="0" spc="-12" kern="0">
-                <a:solidFill>
-                  <a:srgbClr val="F3EEE3"/>
-                </a:solidFill>
-                <a:latin typeface="Be Vietnam Pro" pitchFamily="34" charset="0"/>
-                <a:ea typeface="Be Vietnam Pro" pitchFamily="34" charset="-122"/>
-                <a:cs typeface="Be Vietnam Pro" pitchFamily="34" charset="-120"/>
-              </a:rPr>
-              <a:t> tài</a:t>
-            </a:r>
-            <a:r>
-              <a:rPr lang="en-US" sz="2250" dirty="0" spc="-2" kern="0">
-                <a:solidFill>
-                  <a:srgbClr val="F3EEE3"/>
-                </a:solidFill>
-                <a:latin typeface="Be Vietnam Pro" pitchFamily="34" charset="0"/>
-                <a:ea typeface="Be Vietnam Pro" pitchFamily="34" charset="-122"/>
-                <a:cs typeface="Be Vietnam Pro" pitchFamily="34" charset="-120"/>
-              </a:rPr>
-              <a:t> khoản.</a:t>
+              <a:t> mạng</a:t>
+            </a:r>
+            <a:r>
+              <a:rPr lang="en-US" sz="2250" dirty="0" spc="-9" kern="0">
+                <a:solidFill>
+                  <a:srgbClr val="F3EEE3"/>
+                </a:solidFill>
+                <a:latin typeface="Be Vietnam Pro" pitchFamily="34" charset="0"/>
+                <a:ea typeface="Be Vietnam Pro" pitchFamily="34" charset="-122"/>
+                <a:cs typeface="Be Vietnam Pro" pitchFamily="34" charset="-120"/>
+              </a:rPr>
+              <a:t> blockchain.</a:t>
             </a:r>
             <a:endParaRPr lang="en-US" sz="2250" dirty="0"/>
           </a:p>
@@ -13163,6 +13364,28 @@
                 <a:cs typeface="Be Vietnam Pro" pitchFamily="34" charset="-120"/>
               </a:rPr>
               <a:t> của</a:t>
+            </a:r>
+            <a:r>
+              <a:rPr lang="en-US" sz="2250" dirty="0" spc="-4" kern="0">
+                <a:solidFill>
+                  <a:srgbClr val="F3EEE3"/>
+                </a:solidFill>
+                <a:latin typeface="Be Vietnam Pro" pitchFamily="34" charset="0"/>
+                <a:ea typeface="Be Vietnam Pro" pitchFamily="34" charset="-122"/>
+                <a:cs typeface="Be Vietnam Pro" pitchFamily="34" charset="-120"/>
+              </a:rPr>
+              <a:t> một</a:t>
+            </a:r>
+            <a:r>
+              <a:rPr lang="en-US" sz="2250" dirty="0" spc="-1" kern="0">
+                <a:solidFill>
+                  <a:srgbClr val="F3EEE3"/>
+                </a:solidFill>
+                <a:latin typeface="Be Vietnam Pro" pitchFamily="34" charset="0"/>
+                <a:ea typeface="Be Vietnam Pro" pitchFamily="34" charset="-122"/>
+                <a:cs typeface="Be Vietnam Pro" pitchFamily="34" charset="-120"/>
+              </a:rPr>
+              <a:t> mạng</a:t>
             </a:r>
             <a:r>
               <a:rPr lang="en-US" sz="2250" dirty="0" spc="-9" kern="0">

</xml_diff>